<commit_message>
Finalize pricing workflow and presentation updates
</commit_message>
<xml_diff>
--- a/presentations/ProjectCore_Agent_Shell_Presentation.pptx
+++ b/presentations/ProjectCore_Agent_Shell_Presentation.pptx
@@ -3288,9 +3288,9 @@
                 </a:solidFill>
                 <a:latin typeface="Arial"/>
               </a:rPr>
-              <a:t>Один интерфейс.
-Один агент.
-Один рабочий контур.</a:t>
+              <a:t>Платформа для расчета
+и проектной подготовки
+инженерных систем.</a:t>
             </a:r>
           </a:p>
         </p:txBody>
@@ -3304,7 +3304,7 @@
         <p:spPr>
           <a:xfrm>
             <a:off x="786384" y="3273552"/>
-            <a:ext cx="4617720" cy="987552"/>
+            <a:ext cx="4617720" cy="1024128"/>
           </a:xfrm>
           <a:prstGeom prst="rect">
             <a:avLst/>
@@ -3325,7 +3325,7 @@
                 </a:solidFill>
                 <a:latin typeface="Arial"/>
               </a:rPr>
-              <a:t>ProjectCore Agent Shell объединяет AI-модели, файлы проекта, вложения, скриншоты и git-сценарии в одном сильном продукте для инженерной команды.</a:t>
+              <a:t>ProjectCore Agent Shell помогает быстро сформировать техническое решение, подобрать оборудование, рассчитать стоимость и подготовить прозрачную спецификацию без разрыва между инженерной логикой, ценами и итоговым результатом.</a:t>
             </a:r>
           </a:p>
         </p:txBody>
@@ -3405,7 +3405,7 @@
                 </a:solidFill>
                 <a:latin typeface="Arial"/>
               </a:rPr>
-              <a:t>3 модели</a:t>
+              <a:t>6 систем</a:t>
             </a:r>
           </a:p>
         </p:txBody>
@@ -3440,7 +3440,7 @@
                 </a:solidFill>
                 <a:latin typeface="Arial"/>
               </a:rPr>
-              <a:t>GigaChat, Qwen CLI, Qwen API</a:t>
+              <a:t>АПС, СОУЭ, СОТ, СКУД, СОТС, ССОИ</a:t>
             </a:r>
           </a:p>
         </p:txBody>
@@ -3520,7 +3520,7 @@
                 </a:solidFill>
                 <a:latin typeface="Arial"/>
               </a:rPr>
-              <a:t>1 поток</a:t>
+              <a:t>1 контур</a:t>
             </a:r>
           </a:p>
         </p:txBody>
@@ -3555,7 +3555,7 @@
                 </a:solidFill>
                 <a:latin typeface="Arial"/>
               </a:rPr>
-              <a:t>контекст, запуск, результат</a:t>
+              <a:t>данные, подбор, расчет, спецификация</a:t>
             </a:r>
           </a:p>
         </p:txBody>
@@ -3689,7 +3689,7 @@
         <p:spPr>
           <a:xfrm>
             <a:off x="749808" y="658368"/>
-            <a:ext cx="1572768" cy="347472"/>
+            <a:ext cx="1097280" cy="347472"/>
           </a:xfrm>
           <a:prstGeom prst="roundRect">
             <a:avLst/>
@@ -3729,7 +3729,7 @@
                 </a:solidFill>
                 <a:latin typeface="Arial"/>
               </a:rPr>
-              <a:t>WHY IT MATTERS</a:t>
+              <a:t>PURPOSE</a:t>
             </a:r>
           </a:p>
         </p:txBody>
@@ -3764,7 +3764,7 @@
                 </a:solidFill>
                 <a:latin typeface="Arial"/>
               </a:rPr>
-              <a:t>Не ещё один AI-чат.</a:t>
+              <a:t>Назначение платформы</a:t>
             </a:r>
           </a:p>
         </p:txBody>
@@ -3793,13 +3793,13 @@
           <a:p>
             <a:pPr algn="l"/>
             <a:r>
-              <a:rPr sz="2700" b="1">
+              <a:rPr sz="2100" b="1">
                 <a:solidFill>
                   <a:srgbClr val="FFFFFF"/>
                 </a:solidFill>
                 <a:latin typeface="Arial"/>
               </a:rPr>
-              <a:t>А AI-операционная система команды.</a:t>
+              <a:t>Ускорить подготовку инженерных решений и сделать расчет управляемым.</a:t>
             </a:r>
           </a:p>
         </p:txBody>
@@ -3834,7 +3834,7 @@
                 </a:solidFill>
                 <a:latin typeface="Arial"/>
               </a:rPr>
-              <a:t>Смена провайдера, работа с проектом, вложения, промптинг и git больше не расползаются по окнам и утилитам. Всё собрано в одном управляемом интерфейсе.</a:t>
+              <a:t>Платформа нужна проектным, сметным и коммерческим командам, которым важно быстро получить обоснованную спецификацию, корректный подбор оборудования и расчет стоимости на основе единых правил.</a:t>
             </a:r>
           </a:p>
         </p:txBody>
@@ -3914,7 +3914,7 @@
                 </a:solidFill>
                 <a:latin typeface="Arial"/>
               </a:rPr>
-              <a:t>Быстрее старт</a:t>
+              <a:t>Быстрее расчет</a:t>
             </a:r>
           </a:p>
         </p:txBody>
@@ -3949,7 +3949,7 @@
                 </a:solidFill>
                 <a:latin typeface="Arial"/>
               </a:rPr>
-              <a:t>От задачи до запуска агента без ручной подготовки окружения.</a:t>
+              <a:t>От исходных параметров объекта до предварительной спецификации и бюджета за один рабочий проход.</a:t>
             </a:r>
           </a:p>
         </p:txBody>
@@ -4029,7 +4029,7 @@
                 </a:solidFill>
                 <a:latin typeface="Arial"/>
               </a:rPr>
-              <a:t>Меньше хаоса</a:t>
+              <a:t>Меньше ошибок</a:t>
             </a:r>
           </a:p>
         </p:txBody>
@@ -4064,7 +4064,7 @@
                 </a:solidFill>
                 <a:latin typeface="Arial"/>
               </a:rPr>
-              <a:t>Файлы, скрины и доступы живут рядом, а не теряются по папкам.</a:t>
+              <a:t>Модели, цены, коэффициенты и итоговая структура расчета формируются в едином процессе, а не вручную.</a:t>
             </a:r>
           </a:p>
         </p:txBody>
@@ -4144,7 +4144,7 @@
                 </a:solidFill>
                 <a:latin typeface="Arial"/>
               </a:rPr>
-              <a:t>Сильнее контроль</a:t>
+              <a:t>Прозрачнее результат</a:t>
             </a:r>
           </a:p>
         </p:txBody>
@@ -4179,7 +4179,7 @@
                 </a:solidFill>
                 <a:latin typeface="Arial"/>
               </a:rPr>
-              <a:t>Команда осознанно выбирает модель и git-контур под сценарий.</a:t>
+              <a:t>Пользователь видит логику выбора оборудования, источники цен и может оперативно уточнить решение.</a:t>
             </a:r>
           </a:p>
         </p:txBody>
@@ -4313,7 +4313,7 @@
         <p:spPr>
           <a:xfrm>
             <a:off x="749808" y="640080"/>
-            <a:ext cx="1389888" cy="347472"/>
+            <a:ext cx="1463040" cy="347472"/>
           </a:xfrm>
           <a:prstGeom prst="roundRect">
             <a:avLst/>
@@ -4353,7 +4353,7 @@
                 </a:solidFill>
                 <a:latin typeface="Arial"/>
               </a:rPr>
-              <a:t>REAL PRODUCT</a:t>
+              <a:t>FUNCTIONALITY</a:t>
             </a:r>
           </a:p>
         </p:txBody>
@@ -4388,7 +4388,7 @@
                 </a:solidFill>
                 <a:latin typeface="Arial"/>
               </a:rPr>
-              <a:t>Это уже выглядит как продукт.</a:t>
+              <a:t>Ключевой функционал платформы</a:t>
             </a:r>
           </a:p>
         </p:txBody>
@@ -4423,7 +4423,7 @@
                 </a:solidFill>
                 <a:latin typeface="Arial"/>
               </a:rPr>
-              <a:t>Не как админка. Не как прототип. Не как набор скриптов.</a:t>
+              <a:t>Платформа закрывает весь базовый цикл подготовки инженерного решения.</a:t>
             </a:r>
           </a:p>
         </p:txBody>
@@ -4658,7 +4658,7 @@
                 </a:solidFill>
                 <a:latin typeface="Arial"/>
               </a:rPr>
-              <a:t>Публичная подача</a:t>
+              <a:t>Подбор оборудования</a:t>
             </a:r>
           </a:p>
         </p:txBody>
@@ -4672,7 +4672,7 @@
         <p:spPr>
           <a:xfrm>
             <a:off x="6711696" y="2743200"/>
-            <a:ext cx="4370832" cy="329184"/>
+            <a:ext cx="4370832" cy="438912"/>
           </a:xfrm>
           <a:prstGeom prst="rect">
             <a:avLst/>
@@ -4693,7 +4693,7 @@
                 </a:solidFill>
                 <a:latin typeface="Arial"/>
               </a:rPr>
-              <a:t>С первого экрана понятно, в чём ценность продукта и почему ему можно доверять.</a:t>
+              <a:t>Для каждой из шести систем формируется состав оборудования, конкретные модели, количество и расчетная цена.</a:t>
             </a:r>
           </a:p>
         </p:txBody>
@@ -4773,7 +4773,7 @@
                 </a:solidFill>
                 <a:latin typeface="Arial"/>
               </a:rPr>
-              <a:t>AI-позиционирование</a:t>
+              <a:t>Сравнение и пересчет</a:t>
             </a:r>
           </a:p>
         </p:txBody>
@@ -4787,7 +4787,7 @@
         <p:spPr>
           <a:xfrm>
             <a:off x="6711696" y="4187952"/>
-            <a:ext cx="4389120" cy="329184"/>
+            <a:ext cx="4389120" cy="438912"/>
           </a:xfrm>
           <a:prstGeom prst="rect">
             <a:avLst/>
@@ -4808,7 +4808,7 @@
                 </a:solidFill>
                 <a:latin typeface="Arial"/>
               </a:rPr>
-              <a:t>Не магия, а понятный AI-движок, сценарий применения и инженерный смысл.</a:t>
+              <a:t>Можно сравнивать цены, обновлять источники, менять модель конкретной позиции и сразу видеть новый итог по спецификации.</a:t>
             </a:r>
           </a:p>
         </p:txBody>
@@ -4888,7 +4888,7 @@
                 </a:solidFill>
                 <a:latin typeface="Arial"/>
               </a:rPr>
-              <a:t>Готовность к продаже</a:t>
+              <a:t>Документы на выходе</a:t>
             </a:r>
           </a:p>
         </p:txBody>
@@ -4902,7 +4902,7 @@
         <p:spPr>
           <a:xfrm>
             <a:off x="6711696" y="5559552"/>
-            <a:ext cx="4407408" cy="274320"/>
+            <a:ext cx="4407408" cy="384048"/>
           </a:xfrm>
           <a:prstGeom prst="rect">
             <a:avLst/>
@@ -4923,7 +4923,7 @@
                 </a:solidFill>
                 <a:latin typeface="Arial"/>
               </a:rPr>
-              <a:t>Уже можно показывать клиенту, партнёру, инвестору и внутренней команде.</a:t>
+              <a:t>На выходе пользователь получает спецификацию, бюджетный расчет, структуру стоимости и материалы для дальнейшей работы.</a:t>
             </a:r>
           </a:p>
         </p:txBody>
@@ -5057,7 +5057,7 @@
         <p:spPr>
           <a:xfrm>
             <a:off x="749808" y="658368"/>
-            <a:ext cx="1737360" cy="347472"/>
+            <a:ext cx="1463040" cy="347472"/>
           </a:xfrm>
           <a:prstGeom prst="roundRect">
             <a:avLst/>
@@ -5097,7 +5097,7 @@
                 </a:solidFill>
                 <a:latin typeface="Arial"/>
               </a:rPr>
-              <a:t>FUNCTIONAL STACK</a:t>
+              <a:t>HOW IT WORKS</a:t>
             </a:r>
           </a:p>
         </p:txBody>
@@ -5132,7 +5132,7 @@
                 </a:solidFill>
                 <a:latin typeface="Arial"/>
               </a:rPr>
-              <a:t>Что делает продукт сильным</a:t>
+              <a:t>Принцип работы платформы</a:t>
             </a:r>
           </a:p>
         </p:txBody>
@@ -5210,7 +5210,7 @@
                 </a:solidFill>
                 <a:latin typeface="Arial"/>
               </a:rPr>
-              <a:t>Внутри одного интерфейса:</a:t>
+              <a:t>Шаги расчета:</a:t>
             </a:r>
           </a:p>
         </p:txBody>
@@ -5288,7 +5288,7 @@
                 </a:solidFill>
                 <a:latin typeface="Arial"/>
               </a:rPr>
-              <a:t>переключение между GigaChat, Qwen OAuth CLI и Qwen API</a:t>
+              <a:t>пользователь задает параметры объекта или загружает проектную документацию</a:t>
             </a:r>
           </a:p>
         </p:txBody>
@@ -5366,7 +5366,7 @@
                 </a:solidFill>
                 <a:latin typeface="Arial"/>
               </a:rPr>
-              <a:t>привязка локальной рабочей папки и просмотр структуры проекта</a:t>
+              <a:t>платформа определяет состав систем и подбирает оборудование по выбранному вендору</a:t>
             </a:r>
           </a:p>
         </p:txBody>
@@ -5444,7 +5444,7 @@
                 </a:solidFill>
                 <a:latin typeface="Arial"/>
               </a:rPr>
-              <a:t>добавление файлов и скриншотов прямо в контекст задачи</a:t>
+              <a:t>алгоритм находит конкретные модели, рассчитывает количество и цену по источникам</a:t>
             </a:r>
           </a:p>
         </p:txBody>
@@ -5522,7 +5522,7 @@
                 </a:solidFill>
                 <a:latin typeface="Arial"/>
               </a:rPr>
-              <a:t>управление параметрами модели и доступами без ручной рутины</a:t>
+              <a:t>пользователь может менять модели, коэффициенты и параметры расчета в интерфейсе</a:t>
             </a:r>
           </a:p>
         </p:txBody>
@@ -5600,7 +5600,7 @@
                 </a:solidFill>
                 <a:latin typeface="Arial"/>
               </a:rPr>
-              <a:t>переключение git remote между GitHub и GitVerse</a:t>
+              <a:t>стоимость и спецификация пересчитываются автоматически без ручной сборки таблиц</a:t>
             </a:r>
           </a:p>
         </p:txBody>
@@ -5678,7 +5678,7 @@
                 </a:solidFill>
                 <a:latin typeface="Arial"/>
               </a:rPr>
-              <a:t>запуск агента и получение результата в том же окне</a:t>
+              <a:t>на выходе формируются готовые данные для согласования, сметы и дальнейшей проектной работы</a:t>
             </a:r>
           </a:p>
         </p:txBody>
@@ -5737,7 +5737,7 @@
         <p:spPr>
           <a:xfrm>
             <a:off x="6876288" y="2249424"/>
-            <a:ext cx="1097280" cy="201168"/>
+            <a:ext cx="1645920" cy="201168"/>
           </a:xfrm>
           <a:prstGeom prst="rect">
             <a:avLst/>
@@ -5758,7 +5758,7 @@
                 </a:solidFill>
                 <a:latin typeface="Arial"/>
               </a:rPr>
-              <a:t>Модели</a:t>
+              <a:t>Входные данные</a:t>
             </a:r>
           </a:p>
         </p:txBody>
@@ -5793,7 +5793,7 @@
                 </a:solidFill>
                 <a:latin typeface="Arial"/>
               </a:rPr>
-              <a:t>Команда выбирает нужный интеллект под задачу, бюджет и режим работы.</a:t>
+              <a:t>Площадь, этажность, тип объекта, требования заказчика и, при наличии, проектные материалы.</a:t>
             </a:r>
           </a:p>
         </p:txBody>
@@ -5873,7 +5873,7 @@
                 </a:solidFill>
                 <a:latin typeface="Arial"/>
               </a:rPr>
-              <a:t>Контекст</a:t>
+              <a:t>Алгоритм</a:t>
             </a:r>
           </a:p>
         </p:txBody>
@@ -5908,7 +5908,7 @@
                 </a:solidFill>
                 <a:latin typeface="Arial"/>
               </a:rPr>
-              <a:t>Промпт, файлы и screenshots соединяются в один цельный сценарий работы.</a:t>
+              <a:t>Нормативная логика, библиотека оборудования, правила выбора моделей и механизм проверки ценовых источников.</a:t>
             </a:r>
           </a:p>
         </p:txBody>
@@ -5988,7 +5988,7 @@
                 </a:solidFill>
                 <a:latin typeface="Arial"/>
               </a:rPr>
-              <a:t>Инженерный выход</a:t>
+              <a:t>Результат</a:t>
             </a:r>
           </a:p>
         </p:txBody>
@@ -6002,7 +6002,7 @@
         <p:spPr>
           <a:xfrm>
             <a:off x="6876288" y="5394960"/>
-            <a:ext cx="4023360" cy="347472"/>
+            <a:ext cx="4023360" cy="438912"/>
           </a:xfrm>
           <a:prstGeom prst="rect">
             <a:avLst/>
@@ -6023,7 +6023,7 @@
                 </a:solidFill>
                 <a:latin typeface="Arial"/>
               </a:rPr>
-              <a:t>Продукт доводит работу до результата, а не останавливается на красивом диалоге.</a:t>
+              <a:t>Готовая спецификация, понятная структура стоимости, возможность быстро доработать решение и подготовить коммерческое предложение.</a:t>
             </a:r>
           </a:p>
         </p:txBody>
@@ -6157,7 +6157,7 @@
         <p:spPr>
           <a:xfrm>
             <a:off x="749808" y="658368"/>
-            <a:ext cx="1691640" cy="347472"/>
+            <a:ext cx="1783080" cy="347472"/>
           </a:xfrm>
           <a:prstGeom prst="roundRect">
             <a:avLst/>
@@ -6197,7 +6197,7 @@
                 </a:solidFill>
                 <a:latin typeface="Arial"/>
               </a:rPr>
-              <a:t>PRODUCT SCREENS</a:t>
+              <a:t>SITE &amp; INTERFACE</a:t>
             </a:r>
           </a:p>
         </p:txBody>
@@ -6232,7 +6232,7 @@
                 </a:solidFill>
                 <a:latin typeface="Arial"/>
               </a:rPr>
-              <a:t>Сильная подача строится на реальном интерфейсе.</a:t>
+              <a:t>У платформы есть сайт и рабочий интерфейс.</a:t>
             </a:r>
           </a:p>
         </p:txBody>
@@ -6267,7 +6267,7 @@
                 </a:solidFill>
                 <a:latin typeface="Arial"/>
               </a:rPr>
-              <a:t>Поэтому в презентации нужны не абстрактные блоки, а экраны, которые подтверждают зрелость продукта.</a:t>
+              <a:t>Сайт объясняет продукт, а интерфейс показывает реальную работу платформы на объекте и в расчете.</a:t>
             </a:r>
           </a:p>
         </p:txBody>
@@ -6302,7 +6302,7 @@
                 </a:solidFill>
                 <a:latin typeface="Arial"/>
               </a:rPr>
-              <a:t>Вместо трёх мелких превью здесь должен быть один читаемый экран. Поэтому главный интерфейс показываем крупно.</a:t>
+              <a:t>Это важно для клиента: он видит не только идею, но и готовый инструмент, который можно использовать в операционной работе.</a:t>
             </a:r>
           </a:p>
         </p:txBody>
@@ -6572,8 +6572,8 @@
                 </a:solidFill>
                 <a:latin typeface="Arial"/>
               </a:rPr>
-              <a:t>Карточка проекта,
-параметры и фото</a:t>
+              <a:t>Параметры объекта,
+исходные данные и фото</a:t>
             </a:r>
           </a:p>
         </p:txBody>
@@ -6688,8 +6688,8 @@
                 </a:solidFill>
                 <a:latin typeface="Arial"/>
               </a:rPr>
-              <a:t>Объяснение,
-как формируется расчёт</a:t>
+              <a:t>Пояснение,
+как формируется подбор</a:t>
             </a:r>
           </a:p>
         </p:txBody>
@@ -6804,8 +6804,8 @@
                 </a:solidFill>
                 <a:latin typeface="Arial"/>
               </a:rPr>
-              <a:t>Детализация цены
-и структуры стоимости</a:t>
+              <a:t>Стоимость,
+структура и пересчет</a:t>
             </a:r>
           </a:p>
         </p:txBody>
@@ -6939,7 +6939,7 @@
         <p:spPr>
           <a:xfrm>
             <a:off x="749808" y="658368"/>
-            <a:ext cx="1024128" cy="347472"/>
+            <a:ext cx="1280160" cy="347472"/>
           </a:xfrm>
           <a:prstGeom prst="roundRect">
             <a:avLst/>
@@ -6979,7 +6979,7 @@
                 </a:solidFill>
                 <a:latin typeface="Arial"/>
               </a:rPr>
-              <a:t>WHY NOW</a:t>
+              <a:t>SITE &amp; LEGAL</a:t>
             </a:r>
           </a:p>
         </p:txBody>
@@ -7014,8 +7014,8 @@
                 </a:solidFill>
                 <a:latin typeface="Arial"/>
               </a:rPr>
-              <a:t>Рынок уже готов
-к такому продукту.</a:t>
+              <a:t>На сайте есть раздел
+«О системе».</a:t>
             </a:r>
           </a:p>
         </p:txBody>
@@ -7050,7 +7050,7 @@
                 </a:solidFill>
                 <a:latin typeface="Arial"/>
               </a:rPr>
-              <a:t>AI стал привычным. Но привычным не стал управляемый AI-процесс для команды. ProjectCore Agent Shell закрывает именно этот разрыв.</a:t>
+              <a:t>В этом разделе пользователь получает понятное описание продукта, его назначения, принципа работы и всей юридической информации, необходимой для доверия к платформе.</a:t>
             </a:r>
           </a:p>
         </p:txBody>
@@ -7130,7 +7130,7 @@
                 </a:solidFill>
                 <a:latin typeface="Arial"/>
               </a:rPr>
-              <a:t>AI есть у всех</a:t>
+              <a:t>Описание системы</a:t>
             </a:r>
           </a:p>
         </p:txBody>
@@ -7165,7 +7165,7 @@
                 </a:solidFill>
                 <a:latin typeface="Arial"/>
               </a:rPr>
-              <a:t>Но чаще всего он живёт как отдельный чат, а не как рабочая система.</a:t>
+              <a:t>Сформулировано, для чего нужна платформа, какие задачи она решает и каким командам подходит.</a:t>
             </a:r>
           </a:p>
         </p:txBody>
@@ -7245,7 +7245,7 @@
                 </a:solidFill>
                 <a:latin typeface="Arial"/>
               </a:rPr>
-              <a:t>Команды тонут в инструментах</a:t>
+              <a:t>Юридическая информация</a:t>
             </a:r>
           </a:p>
         </p:txBody>
@@ -7280,7 +7280,7 @@
                 </a:solidFill>
                 <a:latin typeface="Arial"/>
               </a:rPr>
-              <a:t>Скорость теряется на переключении контекста, а не на сложности задачи.</a:t>
+              <a:t>На сайте размещаются реквизиты, правовая информация и сведения, которые важны для заказчика и партнера.</a:t>
             </a:r>
           </a:p>
         </p:txBody>
@@ -7360,7 +7360,7 @@
                 </a:solidFill>
                 <a:latin typeface="Arial"/>
               </a:rPr>
-              <a:t>Нужны зрелые интерфейсы</a:t>
+              <a:t>Инструмент разработчика</a:t>
             </a:r>
           </a:p>
         </p:txBody>
@@ -7395,7 +7395,7 @@
                 </a:solidFill>
                 <a:latin typeface="Arial"/>
               </a:rPr>
-              <a:t>Побеждает не только модель, а то, как она встроена в реальную работу.</a:t>
+              <a:t>Есть отдельный контур для доработки продукта под себя: можно адаптировать платформу под процессы, роль и специфику компании.</a:t>
             </a:r>
           </a:p>
         </p:txBody>
@@ -7624,8 +7624,8 @@
                 <a:latin typeface="Arial"/>
               </a:rPr>
               <a:t>ProjectCore Agent Shell
-выглядит как продукт,
-а не как заготовка.</a:t>
+это платформа с понятным
+назначением и реальной пользой.</a:t>
             </a:r>
           </a:p>
         </p:txBody>
@@ -7639,7 +7639,7 @@
         <p:spPr>
           <a:xfrm>
             <a:off x="786384" y="3401568"/>
-            <a:ext cx="5257800" cy="877824"/>
+            <a:ext cx="5257800" cy="987552"/>
           </a:xfrm>
           <a:prstGeom prst="rect">
             <a:avLst/>
@@ -7660,7 +7660,7 @@
                 </a:solidFill>
                 <a:latin typeface="Arial"/>
               </a:rPr>
-              <a:t>Именно так его и нужно показывать: крупно, смело, с реальными экранами и фотофонами, а не с мелкими карточками на пустом фоне.</a:t>
+              <a:t>В презентации должно быть ясно показано, что платформа умеет, как она работает, где размещена официальная информация о системе и что продукт можно дорабатывать под задачи конкретной команды.</a:t>
             </a:r>
           </a:p>
         </p:txBody>
@@ -7874,7 +7874,7 @@
         <p:spPr>
           <a:xfrm>
             <a:off x="6894576" y="5175504"/>
-            <a:ext cx="3840480" cy="493776"/>
+            <a:ext cx="3840480" cy="621792"/>
           </a:xfrm>
           <a:prstGeom prst="rect">
             <a:avLst/>
@@ -7895,7 +7895,7 @@
                 </a:solidFill>
                 <a:latin typeface="Arial"/>
               </a:rPr>
-              <a:t>Сайт тоже нужно показывать крупно. Один экран, одна мысль, один сильный визуальный акцент.</a:t>
+              <a:t>Сайт подтверждает зрелость продукта: там есть описание системы, юридическая информация и понятная точка входа для клиента, партнера и разработчика.</a:t>
             </a:r>
           </a:p>
         </p:txBody>

</xml_diff>